<commit_message>
Give the dossiers' closing page the group's address in Forel
The contact line of all thirteen generated dossiers named 821 Chemin des
Clapiers, Le Pradet. It now gives Green Solutions Groupe AIM SA,
46 route de la Condémine, 1475 Forel, with the country name in the
dossier's language.

Co-Authored-By: Claude Opus 5 <noreply@anthropic.com>
</commit_message>
<xml_diff>
--- a/public/documents/countries/afrique-du-sud.pptx
+++ b/public/documents/countries/afrique-du-sud.pptx
@@ -3744,7 +3744,7 @@
       </p:sp>
       <p:pic>
         <p:nvPicPr>
-          <p:cNvPr id="5" name="Image 1" descr="C:\Users\Utilisateur\dev\green-solutions-web\public\images\logo-icon.png">    </p:cNvPr>
+          <p:cNvPr id="5" name="Image 1" descr="C:\Users\Utilisateur\dev\gsw-dossiers\public\images\logo-icon.png">    </p:cNvPr>
           <p:cNvPicPr>
             <a:picLocks noChangeAspect="1"/>
           </p:cNvPicPr>
@@ -3768,7 +3768,7 @@
       </p:pic>
       <p:pic>
         <p:nvPicPr>
-          <p:cNvPr id="6" name="Image 2" descr="C:\Users\Utilisateur\dev\green-solutions-web\scripts\dossiers\drapeaux\afrique-du-sud.png">    </p:cNvPr>
+          <p:cNvPr id="6" name="Image 2" descr="C:\Users\Utilisateur\dev\gsw-dossiers\scripts\dossiers\drapeaux\afrique-du-sud.png">    </p:cNvPr>
           <p:cNvPicPr>
             <a:picLocks noChangeAspect="1"/>
           </p:cNvPicPr>
@@ -9535,7 +9535,7 @@
                 <a:ea typeface="Calibri" pitchFamily="34" charset="-122"/>
                 <a:cs typeface="Calibri" pitchFamily="34" charset="-120"/>
               </a:rPr>
-              <a:t>contact@evergreen-ecosorb.com · 821 Chemin des Clapiers, 83220 Le Pradet, France</a:t>
+              <a:t>contact@evergreen-ecosorb.com · Green Solutions Groupe AIM SA, 46, route de la Condémine, 1475 Forel, Switzerland</a:t>
             </a:r>
             <a:endParaRPr lang="en-US" sz="1400" dirty="0"/>
           </a:p>
@@ -9543,7 +9543,7 @@
       </p:sp>
       <p:pic>
         <p:nvPicPr>
-          <p:cNvPr id="6" name="Image 1" descr="C:\Users\Utilisateur\dev\green-solutions-web\scripts\dossiers\sceau-aim-clair.png">    </p:cNvPr>
+          <p:cNvPr id="6" name="Image 1" descr="C:\Users\Utilisateur\dev\gsw-dossiers\scripts\dossiers\sceau-aim-clair.png">    </p:cNvPr>
           <p:cNvPicPr>
             <a:picLocks noChangeAspect="1"/>
           </p:cNvPicPr>

</xml_diff>

<commit_message>
Remplace l'adresse de contact par contact@green-solutions-group.com
Met à jour le formulaire de contact (destinataire, expéditeur et message
d'erreur), les mentions légales, la politique de confidentialité, les
dossiers pays et les scripts de génération, puis régénère les 22 dossiers
pays (PPTX et PDF).

Co-Authored-By: Claude Opus 5.5 <noreply@anthropic.com>
Claude-Session: https://claude.ai/code/session_01VYATCTBhc8yZb64xh1djR1
</commit_message>
<xml_diff>
--- a/public/documents/countries/afrique-du-sud.pptx
+++ b/public/documents/countries/afrique-du-sud.pptx
@@ -4092,7 +4092,7 @@
       </p:sp>
       <p:pic>
         <p:nvPicPr>
-          <p:cNvPr id="5" name="Image 1" descr="/workspace/scratch/50eb4f7d8e13/green-solutions-web/public/images/logo-icon.png">    </p:cNvPr>
+          <p:cNvPr id="5" name="Image 1" descr="/home/claude/green-solutions-web/public/images/logo-icon.png">    </p:cNvPr>
           <p:cNvPicPr>
             <a:picLocks noChangeAspect="1"/>
           </p:cNvPicPr>
@@ -4116,7 +4116,7 @@
       </p:pic>
       <p:pic>
         <p:nvPicPr>
-          <p:cNvPr id="6" name="Image 2" descr="/workspace/scratch/50eb4f7d8e13/green-solutions-web/scripts/dossiers/drapeaux/afrique-du-sud.png">    </p:cNvPr>
+          <p:cNvPr id="6" name="Image 2" descr="/home/claude/green-solutions-web/scripts/dossiers/drapeaux/afrique-du-sud.png">    </p:cNvPr>
           <p:cNvPicPr>
             <a:picLocks noChangeAspect="1"/>
           </p:cNvPicPr>
@@ -10276,7 +10276,7 @@
                 <a:ea typeface="Calibri" pitchFamily="34" charset="-122"/>
                 <a:cs typeface="Calibri" pitchFamily="34" charset="-120"/>
               </a:rPr>
-              <a:t>contact@evergreen-ecosorb.com · Green Solutions Groupe AIM SA, 46, route de la Condémine, 1475 Forel, Switzerland</a:t>
+              <a:t>contact@green-solutions-group.com · Green Solutions Groupe AIM SA, 46, route de la Condémine, 1475 Forel, Switzerland</a:t>
             </a:r>
             <a:endParaRPr lang="en-US" sz="1400" dirty="0"/>
           </a:p>
@@ -10284,7 +10284,7 @@
       </p:sp>
       <p:pic>
         <p:nvPicPr>
-          <p:cNvPr id="6" name="Image 1" descr="/workspace/scratch/50eb4f7d8e13/green-solutions-web/scripts/dossiers/sceau-aim-clair.png">    </p:cNvPr>
+          <p:cNvPr id="6" name="Image 1" descr="/home/claude/green-solutions-web/scripts/dossiers/sceau-aim-clair.png">    </p:cNvPr>
           <p:cNvPicPr>
             <a:picLocks noChangeAspect="1"/>
           </p:cNvPicPr>

</xml_diff>